<commit_message>
Clarify Copilot App customer recommendation and alternatives
State native GitHub work, broad model choice and reusable expertise as the combined best-fit proposition. Cite current Claude Desktop, VS Code and Visual Studio capabilities; preserve evidence boundaries and validate the regenerated PowerPoint and PDF.

Co-authored-by: Copilot <223556219+Copilot@users.noreply.github.com>
</commit_message>
<xml_diff>
--- a/presentation/mosaic-copilot-app-demo-15min.pptx
+++ b/presentation/mosaic-copilot-app-demo-15min.pptx
@@ -138,7 +138,7 @@
   <p:extLst>
     <p:ext uri="{521415D9-36F7-43E2-AB2F-B90AF26B5E84}">
       <p14:sectionLst xmlns:p14="http://schemas.microsoft.com/office/powerpoint/2010/main">
-        <p14:section name="15-minute customer demo" id="{bcd251f9-3ff1-4381-790b-1f45367ca59f}">
+        <p14:section name="15-minute customer demo" id="{31a4644d-2fba-fd70-7357-0fa2e655d79d}">
           <p14:sldIdLst>
             <p14:sldId id="256"/>
             <p14:sldId id="257"/>
@@ -157,7 +157,7 @@
             <p14:sldId id="270"/>
           </p14:sldIdLst>
         </p14:section>
-        <p14:section name="Feature reference - optional Q&amp;A" id="{00e1374b-cd46-c8c5-1bef-313a8c41564b}">
+        <p14:section name="Feature reference - optional Q&amp;A" id="{edc48c01-0099-61e3-d0df-0252a15ac6f6}">
           <p14:sldIdLst>
             <p14:sldId id="271"/>
             <p14:sldId id="272"/>
@@ -172,7 +172,7 @@
             <p14:sldId id="281"/>
           </p14:sldIdLst>
         </p14:section>
-        <p14:section name="Presenter setup and sources" id="{87554de7-c1b3-3e86-bc48-afb5907b8236}">
+        <p14:section name="Presenter setup and sources" id="{5f635bdc-b3d1-d5ac-baa9-a81739e211a2}">
           <p14:sldIdLst>
             <p14:sldId id="282"/>
             <p14:sldId id="283"/>
@@ -589,7 +589,7 @@
               <a:t>TIMING 00:00-00:35 (35 seconds)
 Claim framing: recommendation. Public product sources verified 2026-10-19.
 SPEAKER TALK TRACK
-What if your team's expertise could become a repeatable workflow, rather than another prompt someone has to reconstruct? GitHub Copilot App is a dedicated workspace for directing agent work, connecting context and reviewing results. MOSAIC is our proof point: a business conversation becomes a governed solution-engineering discussion draft. Today, evaluate the App as the working environment, not just the model answering the question. Watch the workflow, then imagine the expertise your team could package next.
+If GitHub is where your team works, make GitHub Copilot App your agent workspace. It combines native GitHub review, broad model choice and reusable expertise in a dedicated desktop experience. MOSAIC makes that recommendation tangible: a business conversation becomes a governed solution-engineering discussion draft. You bring approved context and decision rights; the App brings the working environment. We recommend it for that combination, not because other tools cannot run agents. Watch the workflow, then identify the expertise your team could package next.
 EVIDENCE BOUNDARY
 App proof = authentic recorded use; Configured = assets exist, not execution proof; Extension = proposed MOSAIC use of documented capabilities. A local validation is not App footage. No customer approval, implementation or deployment is claimed.
 SOURCES
@@ -1099,7 +1099,7 @@
               <a:t>TIMING 13:20-14:15 (55 seconds)
 Claim framing: recommendation. Public product sources verified 2026-10-19.
 SPEAKER TALK TRACK
-Start with the synthetic MOSAIC workflow. Then compare Copilot App with your current IDE or execution tool on the same approved task. Keep inputs, evidence, acceptance criteria and reviewer standards comparable; record tool versions, models and all costs. Measure operator effort, handoffs, elapsed time, corrections and output quality. For a Claude Code comparison, run that same task rather than guessing from feature lists. Add approved context or parallelism only when it improves the result. The App complements existing tools; choose it where the working experience earns its place. This demo is not a comparative benchmark.
+Here is the buying decision. If GitHub is your engineering hub, you want broad model choice, and you want reusable team workflows in a dedicated agent workspace, our recommendation is Copilot App. Start with MOSAIC's synthetic example, then one approved pilot. If your current VS Code, Visual Studio or Claude Desktop environment already meets those needs, switching needs a demonstrated benefit. Use the same task and evidence to measure effort, handoffs, quality, corrections and total cost. Retain the IDE and debugger where they help. The recommendation is clear; customer validation determines whether the fit is best for you.
 EVIDENCE BOUNDARY
 App proof = authentic recorded use; Configured = assets exist, not execution proof; Extension = proposed MOSAIC use of documented capabilities. A local validation is not App footage. No customer approval, implementation or deployment is claimed.
 SOURCES
@@ -1109,8 +1109,10 @@
 https://docs.github.com/en/copilot/how-tos/github-copilot-app/customize-github-copilot-app
 S03 - Sessions, modes, worktrees, models, voice and history
 https://docs.github.com/en/copilot/how-tos/github-copilot-app/agent-sessions
-S08 - Microsoft Work IQ: all four marketplace plugins
-https://github.com/microsoft/work-iq/blob/main/PLUGINS.md
+S10 - App BYOK providers and requirements
+https://docs.github.com/en/copilot/how-tos/github-copilot-app/use-byok-models
+S12 - My work, issues, PRs, checks and agent merge
+https://docs.github.com/en/copilot/how-tos/github-copilot-app/managing-issues-and-pull-requests
 M06 - Field reuse and adoption path
 https://github.com/gregunger/ghca-mosaic-challenge-official/blob/4d1865687cdd0cdf6fe0777ac102085a2f1d5c9e/docs/adoption-playbook.md</a:t>
             </a:r>
@@ -1203,7 +1205,7 @@
               <a:t>TIMING 14:15-15:00 (45 seconds)
 Claim framing: recommendation. Public product sources verified 2026-10-19.
 SPEAKER TALK TRACK
-Bring one workflow your team keeps reconstructing. Replay MOSAIC, identify the expertise you could package, and evaluate Copilot App against your current way of working. The App brings the agent engine, extensible workspace and GitHub-connected review. Your team brings approved context, domain expertise and decision rights. MOSAIC shows those pieces working together, with a clear boundary around what is demonstrated and what comes next. The next step is a measured pilot, not a platform replacement promise. Start with one workflow and earn the case to scale.
+Make Copilot App your GitHub agent workspace when this customer profile fits. Start with one workflow your team keeps reconstructing. Replay MOSAIC, package your expertise, and bring the result back to accountable human review. The proposition is native GitHub work, broad model choice and reusable team expertise together, not a claim that agents or MCP are exclusive. The next step is one measured pilot with approved context and clear acceptance criteria. MOSAIC is the example. Your team's next repeatable workflow is the opportunity.
 EVIDENCE BOUNDARY
 App proof = authentic recorded use; Configured = assets exist, not execution proof; Extension = proposed MOSAIC use of documented capabilities. A local validation is not App footage. No customer approval, implementation or deployment is claimed.
 SOURCES
@@ -2537,7 +2539,7 @@
               <a:t>OPTIONAL APPENDIX - not part of the timed demo
 Claim framing: recommendation. Public product sources verified 2026-10-19.
 SPEAKER TALK TRACK
-Use this as a customer selection framework, not a scored vendor comparison. Copilot App combines agent direction, extensibility and GitHub review in a dedicated workspace. IDEs, terminal agents and other desktop agent applications overlap with that surface; no missing competitor capability is asserted here. For Claude Code or any alternative, run the same authorized task, disclose versions, models, settings and customization effort, and retain results. Measure total effort, handoffs, time, corrections, quality and incremental costs. The current MOSAIC evidence is App intake, skill and synthetic MCP use plus the browser handoff. Native fleets, WorkIQ, canvas and hosted PR/CI flows remain proposed MOSAIC extensions. No head-to-head result, feature exclusivity or replacement mandate is claimed.
+The recommendation is Copilot App when a dedicated first-party GitHub workspace, broad model/provider choice and reusable workflows fit the customer. Claude Desktop includes Chat, Cowork and Code; its Code tab supports parallel Git-isolated sessions, connectors, diffs and PR/CI monitoring. Do not describe it as chat-only. VS Code supports orchestration and multiple harnesses, including the shared Copilot runtime; it is not merely an editor. Visual Studio agent mode executes tools and iterates, and its optional newer chat experience uses the shared SDK foundation. The App differentiates its packaged GitHub-centered experience, not exclusive ownership of the engine. Keep the existing tool if it already meets the needs. No same-task benchmark has established superiority here; compare effort, handoffs, quality, time and all costs before scaling. MOSAIC demonstrates the App intake, skill, synthetic MCP and browser handoff; native fleets, WorkIQ, canvas and hosted PR/CI are still extensions.
 EVIDENCE BOUNDARY
 App proof = authentic recorded use; Configured = assets exist, not execution proof; Extension = proposed MOSAIC use of documented capabilities. A local validation is not App footage. No customer approval, implementation or deployment is claimed.
 SOURCES
@@ -2545,12 +2547,16 @@
 https://docs.github.com/en/copilot/concepts/copilot-surfaces/github-copilot-app
 S02 - App instructions, skills, agents, MCP and plugins
 https://docs.github.com/en/copilot/how-tos/github-copilot-app/customize-github-copilot-app
-S03 - Sessions, modes, worktrees, models, voice and history
-https://docs.github.com/en/copilot/how-tos/github-copilot-app/agent-sessions
+S10 - App BYOK providers and requirements
+https://docs.github.com/en/copilot/how-tos/github-copilot-app/use-byok-models
 S12 - My work, issues, PRs, checks and agent merge
 https://docs.github.com/en/copilot/how-tos/github-copilot-app/managing-issues-and-pull-requests
-S15 - Copilot SDK: programmatic use of the CLI engine
-https://github.com/github/copilot-sdk
+S21 - Claude Desktop: Chat, Cowork and Code capabilities
+https://code.claude.com/docs/en/desktop
+S22 - VS Code agent harnesses and shared Copilot runtime
+https://code.visualstudio.com/docs/agents/run/agent-harnesses
+S23 - Visual Studio agent mode and shared SDK foundation
+https://learn.microsoft.com/en-us/visualstudio/ide/copilot-agent-mode?view=visualstudio
 M02 - MOSAIC architecture and implementation boundaries
 https://github.com/gregunger/ghca-mosaic-challenge-official/blob/4d1865687cdd0cdf6fe0777ac102085a2f1d5c9e/docs/architecture.md
 M05 - Illustrative economics and measurement plan
@@ -2991,7 +2997,7 @@
               <a:t>TIMING 01:20-02:15 (55 seconds)
 Claim framing: recommendation. Public product sources verified 2026-10-19.
 SPEAKER TALK TRACK
-Choose the working experience, not a feature checklist. Use an IDE when the main activity is hands-on coding and debugging. Evaluate Copilot App when the main activity is directing agents, supervising parallel work and reviewing results in a GitHub-connected workspace. Build a standalone application when you need a dedicated customer experience and are prepared to own its integration and operations. These choices can coexist. IDEs and other agent applications also offer agents, MCP and Git integration. Our case is the combination in one working environment, not feature exclusivity. MOSAIC demonstrates why that experience matters for preparation beyond code editing.
+Our recommendation rests on three customer needs. First, GitHub is already your system for engineering work: direct agents and review issues, changes and checks in a first-party GitHub workspace. Second, you want model choice: select permitted models and evaluate approved hosted or local BYOK providers in preview. Third, you want expertise to travel: package procedures and integrations as skills, agents, MCP and plugins. Choose Copilot App when you want those needs served together in a dedicated workspace. This is a best-fit recommendation for that customer profile, not a universal winner claim. MOSAIC shows the reusable workflow pattern.
 EVIDENCE BOUNDARY
 App proof = authentic recorded use; Configured = assets exist, not execution proof; Extension = proposed MOSAIC use of documented capabilities. A local validation is not App footage. No customer approval, implementation or deployment is claimed.
 SOURCES
@@ -3001,10 +3007,10 @@
 https://docs.github.com/en/copilot/how-tos/github-copilot-app/customize-github-copilot-app
 S03 - Sessions, modes, worktrees, models, voice and history
 https://docs.github.com/en/copilot/how-tos/github-copilot-app/agent-sessions
+S10 - App BYOK providers and requirements
+https://docs.github.com/en/copilot/how-tos/github-copilot-app/use-byok-models
 S12 - My work, issues, PRs, checks and agent merge
 https://docs.github.com/en/copilot/how-tos/github-copilot-app/managing-issues-and-pull-requests
-S15 - Copilot SDK: programmatic use of the CLI engine
-https://github.com/github/copilot-sdk
 M02 - MOSAIC architecture and implementation boundaries
 https://github.com/gregunger/ghca-mosaic-challenge-official/blob/4d1865687cdd0cdf6fe0777ac102085a2f1d5c9e/docs/architecture.md</a:t>
             </a:r>
@@ -3220,14 +3226,14 @@
 https://github.com/microsoft/playwright-mcp
 S20: Azure DevOps MCP integration
 https://github.com/microsoft/azure-devops-mcp
+S21: Claude Desktop: Chat, Cowork and Code capabilities
+https://code.claude.com/docs/en/desktop
+S22: VS Code agent harnesses and shared Copilot runtime
+https://code.visualstudio.com/docs/agents/run/agent-harnesses
+S23: Visual Studio agent mode and shared SDK foundation
+https://learn.microsoft.com/en-us/visualstudio/ide/copilot-agent-mode?view=visualstudio
 M01: Authentic App/report captures and provenance
 https://github.com/gregunger/ghca-mosaic-challenge-official/blob/4d1865687cdd0cdf6fe0777ac102085a2f1d5c9e/presentation/assets/README.md
-M02: MOSAIC architecture and implementation boundaries
-https://github.com/gregunger/ghca-mosaic-challenge-official/blob/4d1865687cdd0cdf6fe0777ac102085a2f1d5c9e/docs/architecture.md
-M03: Canonical synthetic dossier and human-review record
-https://github.com/gregunger/ghca-mosaic-challenge-official/tree/4d1865687cdd0cdf6fe0777ac102085a2f1d5c9e/examples/synthetic/expected
-M04: Five configured MOSAIC agent profiles
-https://github.com/gregunger/ghca-mosaic-challenge-official/tree/4d1865687cdd0cdf6fe0777ac102085a2f1d5c9e/.github/agents
 PRESENTER ACTION / BOUNDARY
 S references are official GitHub/Microsoft public product documentation read on 2026-10-19; M references are MOSAIC evidence pinned to 4d1865687cdd0cdf6fe0777ac102085a2f1d5c9e. Product documentation is mutable: reverify availability before reuse. The 60 capability mappings cover all 47 entries in the public App slash-command reference and all six built-in skills at this snapshot. This is not a claim to enumerate every third-party plugin or future release. App docs warn that some policy settings differ by surface, and public-code matches may still be generated despite a blocking suggestions policy.
 EVIDENCE BOUNDARY
@@ -3237,14 +3243,14 @@
 https://github.com/microsoft/playwright-mcp
 S20 - Azure DevOps MCP integration
 https://github.com/microsoft/azure-devops-mcp
+S21 - Claude Desktop: Chat, Cowork and Code capabilities
+https://code.claude.com/docs/en/desktop
+S22 - VS Code agent harnesses and shared Copilot runtime
+https://code.visualstudio.com/docs/agents/run/agent-harnesses
+S23 - Visual Studio agent mode and shared SDK foundation
+https://learn.microsoft.com/en-us/visualstudio/ide/copilot-agent-mode?view=visualstudio
 M01 - Authentic App/report captures and provenance
-https://github.com/gregunger/ghca-mosaic-challenge-official/blob/4d1865687cdd0cdf6fe0777ac102085a2f1d5c9e/presentation/assets/README.md
-M02 - MOSAIC architecture and implementation boundaries
-https://github.com/gregunger/ghca-mosaic-challenge-official/blob/4d1865687cdd0cdf6fe0777ac102085a2f1d5c9e/docs/architecture.md
-M03 - Canonical synthetic dossier and human-review record
-https://github.com/gregunger/ghca-mosaic-challenge-official/tree/4d1865687cdd0cdf6fe0777ac102085a2f1d5c9e/examples/synthetic/expected
-M04 - Five configured MOSAIC agent profiles
-https://github.com/gregunger/ghca-mosaic-challenge-official/tree/4d1865687cdd0cdf6fe0777ac102085a2f1d5c9e/.github/agents</a:t>
+https://github.com/gregunger/ghca-mosaic-challenge-official/blob/4d1865687cdd0cdf6fe0777ac102085a2f1d5c9e/presentation/assets/README.md</a:t>
             </a:r>
             <a:endParaRPr lang="en-US" dirty="0"/>
           </a:p>
@@ -3335,6 +3341,12 @@
               <a:t>OPTIONAL APPENDIX - not part of the timed demo
 Claim framing: fact. Public product sources verified 2026-10-19.
 SPEAKER TALK TRACK
+M02: MOSAIC architecture and implementation boundaries
+https://github.com/gregunger/ghca-mosaic-challenge-official/blob/4d1865687cdd0cdf6fe0777ac102085a2f1d5c9e/docs/architecture.md
+M03: Canonical synthetic dossier and human-review record
+https://github.com/gregunger/ghca-mosaic-challenge-official/tree/4d1865687cdd0cdf6fe0777ac102085a2f1d5c9e/examples/synthetic/expected
+M04: Five configured MOSAIC agent profiles
+https://github.com/gregunger/ghca-mosaic-challenge-official/tree/4d1865687cdd0cdf6fe0777ac102085a2f1d5c9e/.github/agents
 M05: Illustrative economics and measurement plan
 https://github.com/gregunger/ghca-mosaic-challenge-official/blob/4d1865687cdd0cdf6fe0777ac102085a2f1d5c9e/docs/evaluation-plan.md#planning-economics
 M06: Field reuse and adoption path
@@ -3346,6 +3358,12 @@
 EVIDENCE BOUNDARY
 App proof = authentic recorded use; Configured = assets exist, not execution proof; Extension = proposed MOSAIC use of documented capabilities. A local validation is not App footage. No customer approval, implementation or deployment is claimed.
 SOURCES
+M02 - MOSAIC architecture and implementation boundaries
+https://github.com/gregunger/ghca-mosaic-challenge-official/blob/4d1865687cdd0cdf6fe0777ac102085a2f1d5c9e/docs/architecture.md
+M03 - Canonical synthetic dossier and human-review record
+https://github.com/gregunger/ghca-mosaic-challenge-official/tree/4d1865687cdd0cdf6fe0777ac102085a2f1d5c9e/examples/synthetic/expected
+M04 - Five configured MOSAIC agent profiles
+https://github.com/gregunger/ghca-mosaic-challenge-official/tree/4d1865687cdd0cdf6fe0777ac102085a2f1d5c9e/.github/agents
 M05 - Illustrative economics and measurement plan
 https://github.com/gregunger/ghca-mosaic-challenge-official/blob/4d1865687cdd0cdf6fe0777ac102085a2f1d5c9e/docs/evaluation-plan.md#planning-economics
 M06 - Field reuse and adoption path
@@ -5022,7 +5040,7 @@
                 <a:ea typeface="Segoe UI" pitchFamily="34" charset="-122"/>
                 <a:cs typeface="Segoe UI" pitchFamily="34" charset="-120"/>
               </a:rPr>
-              <a:t>Direct agent work. Review the outcome.</a:t>
+              <a:t>Your GitHub agent workspace.</a:t>
             </a:r>
             <a:endParaRPr lang="en-US" sz="2500" dirty="0"/>
           </a:p>
@@ -5039,7 +5057,7 @@
                 <a:ea typeface="Segoe UI" pitchFamily="34" charset="-122"/>
                 <a:cs typeface="Segoe UI" pitchFamily="34" charset="-120"/>
               </a:rPr>
-              <a:t>MOSAIC shows the pattern beyond code.</a:t>
+              <a:t>MOSAIC shows expertise becoming workflow.</a:t>
             </a:r>
             <a:endParaRPr lang="en-US" sz="2500" dirty="0"/>
           </a:p>
@@ -8498,7 +8516,7 @@
                 <a:ea typeface="Bahnschrift" pitchFamily="34" charset="-122"/>
                 <a:cs typeface="Bahnschrift" pitchFamily="34" charset="-120"/>
               </a:rPr>
-              <a:t>Prove the fit on your own workflow.</a:t>
+              <a:t>Choose the App when these needs align.</a:t>
             </a:r>
             <a:endParaRPr lang="en-US" sz="3400" dirty="0"/>
           </a:p>
@@ -8560,7 +8578,7 @@
                 <a:ea typeface="Segoe UI" pitchFamily="34" charset="-122"/>
                 <a:cs typeface="Segoe UI" pitchFamily="34" charset="-120"/>
               </a:rPr>
-              <a:t>Sources: S01, S02, S03, S08, M06  |  Synthetic reference; customer decisions remain with people.</a:t>
+              <a:t>Sources: S01, S02, S03, S10, S12, M06  |  Synthetic reference; customer decisions remain with people.</a:t>
             </a:r>
             <a:endParaRPr lang="en-US" sz="900" dirty="0"/>
           </a:p>
@@ -8692,7 +8710,7 @@
                 <a:ea typeface="Segoe UI" pitchFamily="34" charset="-122"/>
                 <a:cs typeface="Segoe UI" pitchFamily="34" charset="-120"/>
               </a:rPr>
-              <a:t>1  Same task</a:t>
+              <a:t>GitHub is home</a:t>
             </a:r>
             <a:endParaRPr lang="en-US" sz="2300" dirty="0"/>
           </a:p>
@@ -8731,7 +8749,7 @@
                 <a:ea typeface="Segoe UI" pitchFamily="34" charset="-122"/>
                 <a:cs typeface="Segoe UI" pitchFamily="34" charset="-120"/>
               </a:rPr>
-              <a:t>Same approved task,</a:t>
+              <a:t>Your requests, code</a:t>
             </a:r>
             <a:endParaRPr lang="en-US" sz="2000" dirty="0"/>
           </a:p>
@@ -8748,7 +8766,24 @@
                 <a:ea typeface="Segoe UI" pitchFamily="34" charset="-122"/>
                 <a:cs typeface="Segoe UI" pitchFamily="34" charset="-120"/>
               </a:rPr>
-              <a:t>evidence and acceptance criteria.</a:t>
+              <a:t>and reviews already</a:t>
+            </a:r>
+            <a:endParaRPr lang="en-US" sz="2000" dirty="0"/>
+          </a:p>
+          <a:p>
+            <a:pPr indent="0" marL="0">
+              <a:buNone/>
+            </a:pPr>
+            <a:r>
+              <a:rPr lang="en-US" sz="2000" dirty="0">
+                <a:solidFill>
+                  <a:srgbClr val="526174"/>
+                </a:solidFill>
+                <a:latin typeface="Segoe UI" pitchFamily="34" charset="0"/>
+                <a:ea typeface="Segoe UI" pitchFamily="34" charset="-122"/>
+                <a:cs typeface="Segoe UI" pitchFamily="34" charset="-120"/>
+              </a:rPr>
+              <a:t>live in GitHub.</a:t>
             </a:r>
             <a:endParaRPr lang="en-US" sz="2000" dirty="0"/>
           </a:p>
@@ -8841,7 +8876,7 @@
                 <a:ea typeface="Segoe UI" pitchFamily="34" charset="-122"/>
                 <a:cs typeface="Segoe UI" pitchFamily="34" charset="-120"/>
               </a:rPr>
-              <a:t>2  Compare</a:t>
+              <a:t>Choice matters</a:t>
             </a:r>
             <a:endParaRPr lang="en-US" sz="2300" dirty="0"/>
           </a:p>
@@ -8880,7 +8915,41 @@
                 <a:ea typeface="Segoe UI" pitchFamily="34" charset="-122"/>
                 <a:cs typeface="Segoe UI" pitchFamily="34" charset="-120"/>
               </a:rPr>
-              <a:t>Copilot App versus your current IDE or execution tool.</a:t>
+              <a:t>You want permitted</a:t>
+            </a:r>
+            <a:endParaRPr lang="en-US" sz="2000" dirty="0"/>
+          </a:p>
+          <a:p>
+            <a:pPr indent="0" marL="0">
+              <a:buNone/>
+            </a:pPr>
+            <a:r>
+              <a:rPr lang="en-US" sz="2000" dirty="0">
+                <a:solidFill>
+                  <a:srgbClr val="526174"/>
+                </a:solidFill>
+                <a:latin typeface="Segoe UI" pitchFamily="34" charset="0"/>
+                <a:ea typeface="Segoe UI" pitchFamily="34" charset="-122"/>
+                <a:cs typeface="Segoe UI" pitchFamily="34" charset="-120"/>
+              </a:rPr>
+              <a:t>models and approved</a:t>
+            </a:r>
+            <a:endParaRPr lang="en-US" sz="2000" dirty="0"/>
+          </a:p>
+          <a:p>
+            <a:pPr indent="0" marL="0">
+              <a:buNone/>
+            </a:pPr>
+            <a:r>
+              <a:rPr lang="en-US" sz="2000" dirty="0">
+                <a:solidFill>
+                  <a:srgbClr val="526174"/>
+                </a:solidFill>
+                <a:latin typeface="Segoe UI" pitchFamily="34" charset="0"/>
+                <a:ea typeface="Segoe UI" pitchFamily="34" charset="-122"/>
+                <a:cs typeface="Segoe UI" pitchFamily="34" charset="-120"/>
+              </a:rPr>
+              <a:t>provider options.</a:t>
             </a:r>
             <a:endParaRPr lang="en-US" sz="2000" dirty="0"/>
           </a:p>
@@ -8973,7 +9042,7 @@
                 <a:ea typeface="Segoe UI" pitchFamily="34" charset="-122"/>
                 <a:cs typeface="Segoe UI" pitchFamily="34" charset="-120"/>
               </a:rPr>
-              <a:t>3  Measure</a:t>
+              <a:t>Expertise scales</a:t>
             </a:r>
             <a:endParaRPr lang="en-US" sz="2300" dirty="0"/>
           </a:p>
@@ -9012,7 +9081,7 @@
                 <a:ea typeface="Segoe UI" pitchFamily="34" charset="-122"/>
                 <a:cs typeface="Segoe UI" pitchFamily="34" charset="-120"/>
               </a:rPr>
-              <a:t>Effort, handoffs,</a:t>
+              <a:t>You want reusable</a:t>
             </a:r>
             <a:endParaRPr lang="en-US" sz="2000" dirty="0"/>
           </a:p>
@@ -9029,7 +9098,7 @@
                 <a:ea typeface="Segoe UI" pitchFamily="34" charset="-122"/>
                 <a:cs typeface="Segoe UI" pitchFamily="34" charset="-120"/>
               </a:rPr>
-              <a:t>cycle time, quality,</a:t>
+              <a:t>team workflows in a</a:t>
             </a:r>
             <a:endParaRPr lang="en-US" sz="2000" dirty="0"/>
           </a:p>
@@ -9046,7 +9115,7 @@
                 <a:ea typeface="Segoe UI" pitchFamily="34" charset="-122"/>
                 <a:cs typeface="Segoe UI" pitchFamily="34" charset="-120"/>
               </a:rPr>
-              <a:t>corrections and cost.</a:t>
+              <a:t>dedicated agent App.</a:t>
             </a:r>
             <a:endParaRPr lang="en-US" sz="2000" dirty="0"/>
           </a:p>
@@ -9139,7 +9208,7 @@
                 <a:ea typeface="Segoe UI" pitchFamily="34" charset="-122"/>
                 <a:cs typeface="Segoe UI" pitchFamily="34" charset="-120"/>
               </a:rPr>
-              <a:t>4  Decide</a:t>
+              <a:t>Start one pilot</a:t>
             </a:r>
             <a:endParaRPr lang="en-US" sz="2300" dirty="0"/>
           </a:p>
@@ -9178,7 +9247,41 @@
                 <a:ea typeface="Segoe UI" pitchFamily="34" charset="-122"/>
                 <a:cs typeface="Segoe UI" pitchFamily="34" charset="-120"/>
               </a:rPr>
-              <a:t>Add approved extensions; scale only where the fit is proven.</a:t>
+              <a:t>Same task and evidence.</a:t>
+            </a:r>
+            <a:endParaRPr lang="en-US" sz="2000" dirty="0"/>
+          </a:p>
+          <a:p>
+            <a:pPr indent="0" marL="0">
+              <a:buNone/>
+            </a:pPr>
+            <a:r>
+              <a:rPr lang="en-US" sz="2000" dirty="0">
+                <a:solidFill>
+                  <a:srgbClr val="526174"/>
+                </a:solidFill>
+                <a:latin typeface="Segoe UI" pitchFamily="34" charset="0"/>
+                <a:ea typeface="Segoe UI" pitchFamily="34" charset="-122"/>
+                <a:cs typeface="Segoe UI" pitchFamily="34" charset="-120"/>
+              </a:rPr>
+              <a:t>Measure effort, handoffs,</a:t>
+            </a:r>
+            <a:endParaRPr lang="en-US" sz="2000" dirty="0"/>
+          </a:p>
+          <a:p>
+            <a:pPr indent="0" marL="0">
+              <a:buNone/>
+            </a:pPr>
+            <a:r>
+              <a:rPr lang="en-US" sz="2000" dirty="0">
+                <a:solidFill>
+                  <a:srgbClr val="526174"/>
+                </a:solidFill>
+                <a:latin typeface="Segoe UI" pitchFamily="34" charset="0"/>
+                <a:ea typeface="Segoe UI" pitchFamily="34" charset="-122"/>
+                <a:cs typeface="Segoe UI" pitchFamily="34" charset="-120"/>
+              </a:rPr>
+              <a:t>quality and total cost.</a:t>
             </a:r>
             <a:endParaRPr lang="en-US" sz="2000" dirty="0"/>
           </a:p>
@@ -9217,7 +9320,7 @@
                 <a:ea typeface="Segoe UI" pitchFamily="34" charset="-122"/>
                 <a:cs typeface="Segoe UI" pitchFamily="34" charset="-120"/>
               </a:rPr>
-              <a:t>Record versions, models and configurations. No head-to-head result is claimed by this demo.</a:t>
+              <a:t>Already satisfied by your IDE or another agent app? Require a measured benefit before switching.</a:t>
             </a:r>
             <a:endParaRPr lang="en-US" sz="1700" dirty="0"/>
           </a:p>
@@ -9283,7 +9386,7 @@
                 <a:ea typeface="Segoe UI" pitchFamily="34" charset="-122"/>
                 <a:cs typeface="Segoe UI" pitchFamily="34" charset="-120"/>
               </a:rPr>
-              <a:t>A feature list is not a benchmark. Prove the workflow advantage with customer evidence.</a:t>
+              <a:t>When these needs align, choose Copilot App for a measured pilot. Keep the IDE where it helps.</a:t>
             </a:r>
             <a:endParaRPr lang="en-US" sz="1750" dirty="0"/>
           </a:p>
@@ -9533,7 +9636,7 @@
                 <a:ea typeface="Bahnschrift" pitchFamily="34" charset="-122"/>
                 <a:cs typeface="Bahnschrift" pitchFamily="34" charset="-120"/>
               </a:rPr>
-              <a:t>Bring your next workflow</a:t>
+              <a:t>Make Copilot App your</a:t>
             </a:r>
             <a:endParaRPr lang="en-US" sz="4700" dirty="0"/>
           </a:p>
@@ -9550,7 +9653,7 @@
                 <a:ea typeface="Bahnschrift" pitchFamily="34" charset="-122"/>
                 <a:cs typeface="Bahnschrift" pitchFamily="34" charset="-120"/>
               </a:rPr>
-              <a:t>to GitHub Copilot App.</a:t>
+              <a:t>GitHub agent workspace.</a:t>
             </a:r>
             <a:endParaRPr lang="en-US" sz="4700" dirty="0"/>
           </a:p>
@@ -9853,7 +9956,7 @@
                   </a:extLst>
                 </a:hlinkClick>
               </a:rPr>
-              <a:t>Compare the fit</a:t>
+              <a:t>Start your pilot</a:t>
             </a:r>
             <a:endParaRPr lang="en-US" sz="2500" dirty="0"/>
           </a:p>
@@ -9892,7 +9995,7 @@
                 <a:ea typeface="Segoe UI" pitchFamily="34" charset="-122"/>
                 <a:cs typeface="Segoe UI" pitchFamily="34" charset="-120"/>
               </a:rPr>
-              <a:t>Measure fit before scaling</a:t>
+              <a:t>One workflow. Prove value.</a:t>
             </a:r>
             <a:endParaRPr lang="en-US" sz="1800" dirty="0"/>
           </a:p>
@@ -9931,7 +10034,7 @@
                 <a:ea typeface="Segoe UI" pitchFamily="34" charset="-122"/>
                 <a:cs typeface="Segoe UI" pitchFamily="34" charset="-120"/>
               </a:rPr>
-              <a:t>Agent engine + extensible workspace + GitHub-connected review.</a:t>
+              <a:t>Native GitHub work + broad model choice + reusable team expertise.</a:t>
             </a:r>
             <a:endParaRPr lang="en-US" sz="1700" dirty="0"/>
           </a:p>
@@ -9948,7 +10051,7 @@
                 <a:ea typeface="Segoe UI" pitchFamily="34" charset="-122"/>
                 <a:cs typeface="Segoe UI" pitchFamily="34" charset="-120"/>
               </a:rPr>
-              <a:t>Your expertise becomes the workflow. People retain the decision rights.</a:t>
+              <a:t>MOSAIC is the example. Your workflow is the opportunity.</a:t>
             </a:r>
             <a:endParaRPr lang="en-US" sz="1700" dirty="0"/>
           </a:p>
@@ -24069,7 +24172,7 @@
                 <a:ea typeface="Bahnschrift" pitchFamily="34" charset="-122"/>
                 <a:cs typeface="Bahnschrift" pitchFamily="34" charset="-120"/>
               </a:rPr>
-              <a:t>Competitive conversation: fit, not feature myths.</a:t>
+              <a:t>Why choose the App over your alternatives?</a:t>
             </a:r>
             <a:endParaRPr lang="en-US" sz="3100" dirty="0"/>
           </a:p>
@@ -24131,7 +24234,7 @@
                 <a:ea typeface="Segoe UI" pitchFamily="34" charset="-122"/>
                 <a:cs typeface="Segoe UI" pitchFamily="34" charset="-120"/>
               </a:rPr>
-              <a:t>Sources: S01, S02, S03, S12, S15, M02, M05  |  Documented surface snapshot: 19 Oct 2026</a:t>
+              <a:t>Sources: S01, S02, S10, S12, S21, S22, S23, M02, M05  |  Documented surface snapshot: 19 Oct 2026</a:t>
             </a:r>
             <a:endParaRPr lang="en-US" sz="900" dirty="0"/>
           </a:p>
@@ -24248,7 +24351,7 @@
                 <a:ea typeface="Segoe UI" pitchFamily="34" charset="-122"/>
                 <a:cs typeface="Segoe UI" pitchFamily="34" charset="-120"/>
               </a:rPr>
-              <a:t>WHEN IT CAN FIT</a:t>
+              <a:t>CAPABILITIES ALREADY AVAILABLE</a:t>
             </a:r>
             <a:endParaRPr lang="en-US" sz="1300" dirty="0"/>
           </a:p>
@@ -24287,7 +24390,7 @@
                 <a:ea typeface="Segoe UI" pitchFamily="34" charset="-122"/>
                 <a:cs typeface="Segoe UI" pitchFamily="34" charset="-120"/>
               </a:rPr>
-              <a:t>WHAT TO EVALUATE</a:t>
+              <a:t>WHEN TO CHOOSE COPILOT APP</a:t>
             </a:r>
             <a:endParaRPr lang="en-US" sz="1300" dirty="0"/>
           </a:p>
@@ -24353,7 +24456,7 @@
                 <a:ea typeface="Segoe UI" pitchFamily="34" charset="-122"/>
                 <a:cs typeface="Segoe UI" pitchFamily="34" charset="-120"/>
               </a:rPr>
-              <a:t>IDE</a:t>
+              <a:t>Claude Desktop</a:t>
             </a:r>
             <a:endParaRPr lang="en-US" sz="1800" dirty="0"/>
           </a:p>
@@ -24392,7 +24495,7 @@
                 <a:ea typeface="Segoe UI" pitchFamily="34" charset="-122"/>
                 <a:cs typeface="Segoe UI" pitchFamily="34" charset="-120"/>
               </a:rPr>
-              <a:t>Keep hands-on editing and debugging.</a:t>
+              <a:t>Chat, Cowork + Code; parallel Git sessions, tools and PR / CI.</a:t>
             </a:r>
             <a:endParaRPr lang="en-US" sz="1700" dirty="0"/>
           </a:p>
@@ -24431,7 +24534,7 @@
                 <a:ea typeface="Segoe UI" pitchFamily="34" charset="-122"/>
                 <a:cs typeface="Segoe UI" pitchFamily="34" charset="-120"/>
               </a:rPr>
-              <a:t>Compare workflow supervision + review handoffs.</a:t>
+              <a:t>GitHub-first workspace and broad model/provider choice.</a:t>
             </a:r>
             <a:endParaRPr lang="en-US" sz="1700" dirty="0"/>
           </a:p>
@@ -24497,7 +24600,7 @@
                 <a:ea typeface="Segoe UI" pitchFamily="34" charset="-122"/>
                 <a:cs typeface="Segoe UI" pitchFamily="34" charset="-120"/>
               </a:rPr>
-              <a:t>Terminal / CLI runner</a:t>
+              <a:t>VS Code</a:t>
             </a:r>
             <a:endParaRPr lang="en-US" sz="1800" dirty="0"/>
           </a:p>
@@ -24536,7 +24639,7 @@
                 <a:ea typeface="Segoe UI" pitchFamily="34" charset="-122"/>
                 <a:cs typeface="Segoe UI" pitchFamily="34" charset="-120"/>
               </a:rPr>
-              <a:t>Keep scriptable execution and automation.</a:t>
+              <a:t>Orchestration, multiple harnesses and shared Copilot runtime.</a:t>
             </a:r>
             <a:endParaRPr lang="en-US" sz="1700" dirty="0"/>
           </a:p>
@@ -24575,7 +24678,7 @@
                 <a:ea typeface="Segoe UI" pitchFamily="34" charset="-122"/>
                 <a:cs typeface="Segoe UI" pitchFamily="34" charset="-120"/>
               </a:rPr>
-              <a:t>Compare session visibility + GitHub review.</a:t>
+              <a:t>Prefer a dedicated GitHub workspace; retain the IDE as needed.</a:t>
             </a:r>
             <a:endParaRPr lang="en-US" sz="1700" dirty="0"/>
           </a:p>
@@ -24641,7 +24744,7 @@
                 <a:ea typeface="Segoe UI" pitchFamily="34" charset="-122"/>
                 <a:cs typeface="Segoe UI" pitchFamily="34" charset="-120"/>
               </a:rPr>
-              <a:t>Other agent apps</a:t>
+              <a:t>Visual Studio</a:t>
             </a:r>
             <a:endParaRPr lang="en-US" sz="1800" dirty="0"/>
           </a:p>
@@ -24680,7 +24783,7 @@
                 <a:ea typeface="Segoe UI" pitchFamily="34" charset="-122"/>
                 <a:cs typeface="Segoe UI" pitchFamily="34" charset="-120"/>
               </a:rPr>
-              <a:t>Include Claude Code in a same-task trial.</a:t>
+              <a:t>Agent tools, iteration and optional shared SDK foundation.</a:t>
             </a:r>
             <a:endParaRPr lang="en-US" sz="1700" dirty="0"/>
           </a:p>
@@ -24719,7 +24822,7 @@
                 <a:ea typeface="Segoe UI" pitchFamily="34" charset="-122"/>
                 <a:cs typeface="Segoe UI" pitchFamily="34" charset="-120"/>
               </a:rPr>
-              <a:t>Compare the end-to-end experience, not model rank.</a:t>
+              <a:t>Prefer GitHub-centered supervision; keep IDE debugging.</a:t>
             </a:r>
             <a:endParaRPr lang="en-US" sz="1700" dirty="0"/>
           </a:p>
@@ -24785,7 +24888,7 @@
                 <a:ea typeface="Segoe UI" pitchFamily="34" charset="-122"/>
                 <a:cs typeface="Segoe UI" pitchFamily="34" charset="-120"/>
               </a:rPr>
-              <a:t>Custom application</a:t>
+              <a:t>Other apps / engines</a:t>
             </a:r>
             <a:endParaRPr lang="en-US" sz="1800" dirty="0"/>
           </a:p>
@@ -24824,7 +24927,7 @@
                 <a:ea typeface="Segoe UI" pitchFamily="34" charset="-122"/>
                 <a:cs typeface="Segoe UI" pitchFamily="34" charset="-120"/>
               </a:rPr>
-              <a:t>Build a dedicated customer interface when needed.</a:t>
+              <a:t>Capabilities vary; custom apps own their user experience.</a:t>
             </a:r>
             <a:endParaRPr lang="en-US" sz="1700" dirty="0"/>
           </a:p>
@@ -24863,7 +24966,7 @@
                 <a:ea typeface="Segoe UI" pitchFamily="34" charset="-122"/>
                 <a:cs typeface="Segoe UI" pitchFamily="34" charset="-120"/>
               </a:rPr>
-              <a:t>Compare integration, maintenance and user needs.</a:t>
+              <a:t>Evaluate workflow fit, integration and operating effort.</a:t>
             </a:r>
             <a:endParaRPr lang="en-US" sz="1700" dirty="0"/>
           </a:p>
@@ -25313,7 +25416,7 @@
                 <a:ea typeface="Segoe UI" pitchFamily="34" charset="-122"/>
                 <a:cs typeface="Segoe UI" pitchFamily="34" charset="-120"/>
               </a:rPr>
-              <a:t>Business need + why the App versus alternatives</a:t>
+              <a:t>Business need + three reasons to choose the App</a:t>
             </a:r>
             <a:endParaRPr lang="en-US" sz="2000" dirty="0"/>
           </a:p>
@@ -25625,7 +25728,7 @@
                 <a:ea typeface="Segoe UI" pitchFamily="34" charset="-122"/>
                 <a:cs typeface="Segoe UI" pitchFamily="34" charset="-120"/>
               </a:rPr>
-              <a:t>Adoption path + customer next step</a:t>
+              <a:t>Best-fit customer + recommended pilot</a:t>
             </a:r>
             <a:endParaRPr lang="en-US" sz="2000" dirty="0"/>
           </a:p>
@@ -28148,7 +28251,7 @@
                 <a:ea typeface="Bahnschrift" pitchFamily="34" charset="-122"/>
                 <a:cs typeface="Bahnschrift" pitchFamily="34" charset="-120"/>
               </a:rPr>
-              <a:t>Why the App? Direct work, not just code.</a:t>
+              <a:t>Why choose Copilot App for GitHub teams?</a:t>
             </a:r>
             <a:endParaRPr lang="en-US" sz="3400" dirty="0"/>
           </a:p>
@@ -28210,7 +28313,7 @@
                 <a:ea typeface="Segoe UI" pitchFamily="34" charset="-122"/>
                 <a:cs typeface="Segoe UI" pitchFamily="34" charset="-120"/>
               </a:rPr>
-              <a:t>Sources: S01, S02, S03, S12, S15, M02  |  Synthetic reference; customer decisions remain with people.</a:t>
+              <a:t>Sources: S01, S02, S03, S10, S12, M02  |  Synthetic reference; customer decisions remain with people.</a:t>
             </a:r>
             <a:endParaRPr lang="en-US" sz="900" dirty="0"/>
           </a:p>
@@ -28309,13 +28412,13 @@
             <a:r>
               <a:rPr lang="en-US" sz="1400" b="1" dirty="0">
                 <a:solidFill>
-                  <a:srgbClr val="8250DF"/>
-                </a:solidFill>
-                <a:latin typeface="Segoe UI" pitchFamily="34" charset="0"/>
-                <a:ea typeface="Segoe UI" pitchFamily="34" charset="-122"/>
-                <a:cs typeface="Segoe UI" pitchFamily="34" charset="-120"/>
-              </a:rPr>
-              <a:t>IDE</a:t>
+                  <a:srgbClr val="0969DA"/>
+                </a:solidFill>
+                <a:latin typeface="Segoe UI" pitchFamily="34" charset="0"/>
+                <a:ea typeface="Segoe UI" pitchFamily="34" charset="-122"/>
+                <a:cs typeface="Segoe UI" pitchFamily="34" charset="-120"/>
+              </a:rPr>
+              <a:t>NATIVE GITHUB WORK</a:t>
             </a:r>
             <a:endParaRPr lang="en-US" sz="1400" dirty="0"/>
           </a:p>
@@ -28348,13 +28451,13 @@
             <a:r>
               <a:rPr lang="en-US" sz="2500" b="1" dirty="0">
                 <a:solidFill>
-                  <a:srgbClr val="14202B"/>
-                </a:solidFill>
-                <a:latin typeface="Segoe UI" pitchFamily="34" charset="0"/>
-                <a:ea typeface="Segoe UI" pitchFamily="34" charset="-122"/>
-                <a:cs typeface="Segoe UI" pitchFamily="34" charset="-120"/>
-              </a:rPr>
-              <a:t>Hands-on coding</a:t>
+                  <a:srgbClr val="0969DA"/>
+                </a:solidFill>
+                <a:latin typeface="Segoe UI" pitchFamily="34" charset="0"/>
+                <a:ea typeface="Segoe UI" pitchFamily="34" charset="-122"/>
+                <a:cs typeface="Segoe UI" pitchFamily="34" charset="-120"/>
+              </a:rPr>
+              <a:t>Work to review</a:t>
             </a:r>
             <a:endParaRPr lang="en-US" sz="2500" dirty="0"/>
           </a:p>
@@ -28393,7 +28496,7 @@
                 <a:ea typeface="Segoe UI" pitchFamily="34" charset="-122"/>
                 <a:cs typeface="Segoe UI" pitchFamily="34" charset="-120"/>
               </a:rPr>
-              <a:t>Edit, debug and refine</a:t>
+              <a:t>Issues, agent sessions,</a:t>
             </a:r>
             <a:endParaRPr lang="en-US" sz="1800" dirty="0"/>
           </a:p>
@@ -28410,7 +28513,7 @@
                 <a:ea typeface="Segoe UI" pitchFamily="34" charset="-122"/>
                 <a:cs typeface="Segoe UI" pitchFamily="34" charset="-120"/>
               </a:rPr>
-              <a:t>software directly.</a:t>
+              <a:t>diffs, PRs and CI in one App.</a:t>
             </a:r>
             <a:endParaRPr lang="en-US" sz="1800" dirty="0"/>
           </a:p>
@@ -28425,167 +28528,6 @@
         <p:spPr>
           <a:xfrm>
             <a:off x="4315968" y="1828800"/>
-            <a:ext cx="3557016" cy="2670048"/>
-          </a:xfrm>
-          <a:prstGeom prst="roundRect">
-            <a:avLst>
-              <a:gd name="adj" fmla="val 4110"/>
-            </a:avLst>
-          </a:prstGeom>
-          <a:solidFill>
-            <a:srgbClr val="E7EEF8"/>
-          </a:solidFill>
-          <a:ln w="8890">
-            <a:solidFill>
-              <a:srgbClr val="D4DDE7"/>
-            </a:solidFill>
-            <a:prstDash val="solid"/>
-          </a:ln>
-        </p:spPr>
-      </p:sp>
-      <p:sp>
-        <p:nvSpPr>
-          <p:cNvPr id="14" name="label"/>
-          <p:cNvSpPr txBox="1"/>
-          <p:nvPr/>
-        </p:nvSpPr>
-        <p:spPr>
-          <a:xfrm>
-            <a:off x="4489704" y="2029968"/>
-            <a:ext cx="3209544" cy="283464"/>
-          </a:xfrm>
-          <a:prstGeom prst="rect">
-            <a:avLst/>
-          </a:prstGeom>
-          <a:noFill/>
-          <a:ln/>
-        </p:spPr>
-        <p:txBody>
-          <a:bodyPr wrap="square" lIns="0" tIns="0" rIns="0" bIns="0" rtlCol="0" anchor="ctr"/>
-          <a:lstStyle/>
-          <a:p>
-            <a:pPr indent="0" marL="0">
-              <a:buNone/>
-            </a:pPr>
-            <a:r>
-              <a:rPr lang="en-US" sz="1400" b="1" dirty="0">
-                <a:solidFill>
-                  <a:srgbClr val="0969DA"/>
-                </a:solidFill>
-                <a:latin typeface="Segoe UI" pitchFamily="34" charset="0"/>
-                <a:ea typeface="Segoe UI" pitchFamily="34" charset="-122"/>
-                <a:cs typeface="Segoe UI" pitchFamily="34" charset="-120"/>
-              </a:rPr>
-              <a:t>GITHUB COPILOT APP</a:t>
-            </a:r>
-            <a:endParaRPr lang="en-US" sz="1400" dirty="0"/>
-          </a:p>
-        </p:txBody>
-      </p:sp>
-      <p:sp>
-        <p:nvSpPr>
-          <p:cNvPr id="15" name="content"/>
-          <p:cNvSpPr txBox="1"/>
-          <p:nvPr/>
-        </p:nvSpPr>
-        <p:spPr>
-          <a:xfrm>
-            <a:off x="4489704" y="2688336"/>
-            <a:ext cx="3209544" cy="612648"/>
-          </a:xfrm>
-          <a:prstGeom prst="rect">
-            <a:avLst/>
-          </a:prstGeom>
-          <a:noFill/>
-          <a:ln/>
-        </p:spPr>
-        <p:txBody>
-          <a:bodyPr wrap="square" lIns="0" tIns="0" rIns="0" bIns="0" rtlCol="0" anchor="ctr"/>
-          <a:lstStyle/>
-          <a:p>
-            <a:pPr indent="0" marL="0">
-              <a:buNone/>
-            </a:pPr>
-            <a:r>
-              <a:rPr lang="en-US" sz="2500" b="1" dirty="0">
-                <a:solidFill>
-                  <a:srgbClr val="0969DA"/>
-                </a:solidFill>
-                <a:latin typeface="Segoe UI" pitchFamily="34" charset="0"/>
-                <a:ea typeface="Segoe UI" pitchFamily="34" charset="-122"/>
-                <a:cs typeface="Segoe UI" pitchFamily="34" charset="-120"/>
-              </a:rPr>
-              <a:t>Agent-directed work</a:t>
-            </a:r>
-            <a:endParaRPr lang="en-US" sz="2500" dirty="0"/>
-          </a:p>
-        </p:txBody>
-      </p:sp>
-      <p:sp>
-        <p:nvSpPr>
-          <p:cNvPr id="16" name="diagram"/>
-          <p:cNvSpPr txBox="1"/>
-          <p:nvPr/>
-        </p:nvSpPr>
-        <p:spPr>
-          <a:xfrm>
-            <a:off x="4489704" y="3621024"/>
-            <a:ext cx="3209544" cy="612648"/>
-          </a:xfrm>
-          <a:prstGeom prst="rect">
-            <a:avLst/>
-          </a:prstGeom>
-          <a:noFill/>
-          <a:ln/>
-        </p:spPr>
-        <p:txBody>
-          <a:bodyPr wrap="square" lIns="0" tIns="0" rIns="0" bIns="0" rtlCol="0" anchor="ctr"/>
-          <a:lstStyle/>
-          <a:p>
-            <a:pPr indent="0" marL="0">
-              <a:buNone/>
-            </a:pPr>
-            <a:r>
-              <a:rPr lang="en-US" sz="1800" dirty="0">
-                <a:solidFill>
-                  <a:srgbClr val="526174"/>
-                </a:solidFill>
-                <a:latin typeface="Segoe UI" pitchFamily="34" charset="0"/>
-                <a:ea typeface="Segoe UI" pitchFamily="34" charset="-122"/>
-                <a:cs typeface="Segoe UI" pitchFamily="34" charset="-120"/>
-              </a:rPr>
-              <a:t>Direct sessions, inspect results</a:t>
-            </a:r>
-            <a:endParaRPr lang="en-US" sz="1800" dirty="0"/>
-          </a:p>
-          <a:p>
-            <a:pPr indent="0" marL="0">
-              <a:buNone/>
-            </a:pPr>
-            <a:r>
-              <a:rPr lang="en-US" sz="1800" dirty="0">
-                <a:solidFill>
-                  <a:srgbClr val="526174"/>
-                </a:solidFill>
-                <a:latin typeface="Segoe UI" pitchFamily="34" charset="0"/>
-                <a:ea typeface="Segoe UI" pitchFamily="34" charset="-122"/>
-                <a:cs typeface="Segoe UI" pitchFamily="34" charset="-120"/>
-              </a:rPr>
-              <a:t>and review work with GitHub.</a:t>
-            </a:r>
-            <a:endParaRPr lang="en-US" sz="1800" dirty="0"/>
-          </a:p>
-        </p:txBody>
-      </p:sp>
-      <p:sp>
-        <p:nvSpPr>
-          <p:cNvPr id="17" name="layout-panel"/>
-          <p:cNvSpPr/>
-          <p:nvPr/>
-        </p:nvSpPr>
-        <p:spPr>
-          <a:xfrm>
-            <a:off x="8083296" y="1828800"/>
             <a:ext cx="3557016" cy="2670048"/>
           </a:xfrm>
           <a:prstGeom prst="roundRect">
@@ -28606,6 +28548,167 @@
       </p:sp>
       <p:sp>
         <p:nvSpPr>
+          <p:cNvPr id="14" name="label"/>
+          <p:cNvSpPr txBox="1"/>
+          <p:nvPr/>
+        </p:nvSpPr>
+        <p:spPr>
+          <a:xfrm>
+            <a:off x="4489704" y="2029968"/>
+            <a:ext cx="3209544" cy="283464"/>
+          </a:xfrm>
+          <a:prstGeom prst="rect">
+            <a:avLst/>
+          </a:prstGeom>
+          <a:noFill/>
+          <a:ln/>
+        </p:spPr>
+        <p:txBody>
+          <a:bodyPr wrap="square" lIns="0" tIns="0" rIns="0" bIns="0" rtlCol="0" anchor="ctr"/>
+          <a:lstStyle/>
+          <a:p>
+            <a:pPr indent="0" marL="0">
+              <a:buNone/>
+            </a:pPr>
+            <a:r>
+              <a:rPr lang="en-US" sz="1400" b="1" dirty="0">
+                <a:solidFill>
+                  <a:srgbClr val="8250DF"/>
+                </a:solidFill>
+                <a:latin typeface="Segoe UI" pitchFamily="34" charset="0"/>
+                <a:ea typeface="Segoe UI" pitchFamily="34" charset="-122"/>
+                <a:cs typeface="Segoe UI" pitchFamily="34" charset="-120"/>
+              </a:rPr>
+              <a:t>BROAD MODEL CHOICE</a:t>
+            </a:r>
+            <a:endParaRPr lang="en-US" sz="1400" dirty="0"/>
+          </a:p>
+        </p:txBody>
+      </p:sp>
+      <p:sp>
+        <p:nvSpPr>
+          <p:cNvPr id="15" name="content"/>
+          <p:cNvSpPr txBox="1"/>
+          <p:nvPr/>
+        </p:nvSpPr>
+        <p:spPr>
+          <a:xfrm>
+            <a:off x="4489704" y="2688336"/>
+            <a:ext cx="3209544" cy="612648"/>
+          </a:xfrm>
+          <a:prstGeom prst="rect">
+            <a:avLst/>
+          </a:prstGeom>
+          <a:noFill/>
+          <a:ln/>
+        </p:spPr>
+        <p:txBody>
+          <a:bodyPr wrap="square" lIns="0" tIns="0" rIns="0" bIns="0" rtlCol="0" anchor="ctr"/>
+          <a:lstStyle/>
+          <a:p>
+            <a:pPr indent="0" marL="0">
+              <a:buNone/>
+            </a:pPr>
+            <a:r>
+              <a:rPr lang="en-US" sz="2500" b="1" dirty="0">
+                <a:solidFill>
+                  <a:srgbClr val="8250DF"/>
+                </a:solidFill>
+                <a:latin typeface="Segoe UI" pitchFamily="34" charset="0"/>
+                <a:ea typeface="Segoe UI" pitchFamily="34" charset="-122"/>
+                <a:cs typeface="Segoe UI" pitchFamily="34" charset="-120"/>
+              </a:rPr>
+              <a:t>Choose your model</a:t>
+            </a:r>
+            <a:endParaRPr lang="en-US" sz="2500" dirty="0"/>
+          </a:p>
+        </p:txBody>
+      </p:sp>
+      <p:sp>
+        <p:nvSpPr>
+          <p:cNvPr id="16" name="diagram"/>
+          <p:cNvSpPr txBox="1"/>
+          <p:nvPr/>
+        </p:nvSpPr>
+        <p:spPr>
+          <a:xfrm>
+            <a:off x="4489704" y="3621024"/>
+            <a:ext cx="3209544" cy="612648"/>
+          </a:xfrm>
+          <a:prstGeom prst="rect">
+            <a:avLst/>
+          </a:prstGeom>
+          <a:noFill/>
+          <a:ln/>
+        </p:spPr>
+        <p:txBody>
+          <a:bodyPr wrap="square" lIns="0" tIns="0" rIns="0" bIns="0" rtlCol="0" anchor="ctr"/>
+          <a:lstStyle/>
+          <a:p>
+            <a:pPr indent="0" marL="0">
+              <a:buNone/>
+            </a:pPr>
+            <a:r>
+              <a:rPr lang="en-US" sz="1800" dirty="0">
+                <a:solidFill>
+                  <a:srgbClr val="526174"/>
+                </a:solidFill>
+                <a:latin typeface="Segoe UI" pitchFamily="34" charset="0"/>
+                <a:ea typeface="Segoe UI" pitchFamily="34" charset="-122"/>
+                <a:cs typeface="Segoe UI" pitchFamily="34" charset="-120"/>
+              </a:rPr>
+              <a:t>Permitted models + approved</a:t>
+            </a:r>
+            <a:endParaRPr lang="en-US" sz="1800" dirty="0"/>
+          </a:p>
+          <a:p>
+            <a:pPr indent="0" marL="0">
+              <a:buNone/>
+            </a:pPr>
+            <a:r>
+              <a:rPr lang="en-US" sz="1800" dirty="0">
+                <a:solidFill>
+                  <a:srgbClr val="526174"/>
+                </a:solidFill>
+                <a:latin typeface="Segoe UI" pitchFamily="34" charset="0"/>
+                <a:ea typeface="Segoe UI" pitchFamily="34" charset="-122"/>
+                <a:cs typeface="Segoe UI" pitchFamily="34" charset="-120"/>
+              </a:rPr>
+              <a:t>hosted or local BYOK providers.</a:t>
+            </a:r>
+            <a:endParaRPr lang="en-US" sz="1800" dirty="0"/>
+          </a:p>
+        </p:txBody>
+      </p:sp>
+      <p:sp>
+        <p:nvSpPr>
+          <p:cNvPr id="17" name="layout-panel"/>
+          <p:cNvSpPr/>
+          <p:nvPr/>
+        </p:nvSpPr>
+        <p:spPr>
+          <a:xfrm>
+            <a:off x="8083296" y="1828800"/>
+            <a:ext cx="3557016" cy="2670048"/>
+          </a:xfrm>
+          <a:prstGeom prst="roundRect">
+            <a:avLst>
+              <a:gd name="adj" fmla="val 4110"/>
+            </a:avLst>
+          </a:prstGeom>
+          <a:solidFill>
+            <a:srgbClr val="FFFFFF"/>
+          </a:solidFill>
+          <a:ln w="8890">
+            <a:solidFill>
+              <a:srgbClr val="D4DDE7"/>
+            </a:solidFill>
+            <a:prstDash val="solid"/>
+          </a:ln>
+        </p:spPr>
+      </p:sp>
+      <p:sp>
+        <p:nvSpPr>
           <p:cNvPr id="18" name="label"/>
           <p:cNvSpPr txBox="1"/>
           <p:nvPr/>
@@ -28637,7 +28740,7 @@
                 <a:ea typeface="Segoe UI" pitchFamily="34" charset="-122"/>
                 <a:cs typeface="Segoe UI" pitchFamily="34" charset="-120"/>
               </a:rPr>
-              <a:t>STANDALONE APPLICATION</a:t>
+              <a:t>REUSABLE EXPERTISE</a:t>
             </a:r>
             <a:endParaRPr lang="en-US" sz="1400" dirty="0"/>
           </a:p>
@@ -28670,13 +28773,13 @@
             <a:r>
               <a:rPr lang="en-US" sz="2500" b="1" dirty="0">
                 <a:solidFill>
-                  <a:srgbClr val="14202B"/>
-                </a:solidFill>
-                <a:latin typeface="Segoe UI" pitchFamily="34" charset="0"/>
-                <a:ea typeface="Segoe UI" pitchFamily="34" charset="-122"/>
-                <a:cs typeface="Segoe UI" pitchFamily="34" charset="-120"/>
-              </a:rPr>
-              <a:t>Your own experience</a:t>
+                  <a:srgbClr val="1A7F37"/>
+                </a:solidFill>
+                <a:latin typeface="Segoe UI" pitchFamily="34" charset="0"/>
+                <a:ea typeface="Segoe UI" pitchFamily="34" charset="-122"/>
+                <a:cs typeface="Segoe UI" pitchFamily="34" charset="-120"/>
+              </a:rPr>
+              <a:t>Scale your practice</a:t>
             </a:r>
             <a:endParaRPr lang="en-US" sz="2500" dirty="0"/>
           </a:p>
@@ -28715,7 +28818,7 @@
                 <a:ea typeface="Segoe UI" pitchFamily="34" charset="-122"/>
                 <a:cs typeface="Segoe UI" pitchFamily="34" charset="-120"/>
               </a:rPr>
-              <a:t>Own the product interface,</a:t>
+              <a:t>Skills, agents, MCP and plugins</a:t>
             </a:r>
             <a:endParaRPr lang="en-US" sz="1800" dirty="0"/>
           </a:p>
@@ -28732,7 +28835,7 @@
                 <a:ea typeface="Segoe UI" pitchFamily="34" charset="-122"/>
                 <a:cs typeface="Segoe UI" pitchFamily="34" charset="-120"/>
               </a:rPr>
-              <a:t>integration and operations.</a:t>
+              <a:t>carry your way of working.</a:t>
             </a:r>
             <a:endParaRPr lang="en-US" sz="1800" dirty="0"/>
           </a:p>
@@ -28771,7 +28874,7 @@
                 <a:ea typeface="Segoe UI" pitchFamily="34" charset="-122"/>
                 <a:cs typeface="Segoe UI" pitchFamily="34" charset="-120"/>
               </a:rPr>
-              <a:t>Selection lenses, not exclusive capabilities. IDEs and other agent tools also support agents, MCP and Git.</a:t>
+              <a:t>The differentiator is the combined first-party GitHub experience, not exclusive features. BYOK is preview.</a:t>
             </a:r>
             <a:endParaRPr lang="en-US" sz="1800" dirty="0"/>
           </a:p>
@@ -28837,7 +28940,7 @@
                 <a:ea typeface="Segoe UI" pitchFamily="34" charset="-122"/>
                 <a:cs typeface="Segoe UI" pitchFamily="34" charset="-120"/>
               </a:rPr>
-              <a:t>Choose the complete working experience. Keep the IDE where it adds value.</a:t>
+              <a:t>Our recommendation for GitHub-centered teams: put these needs together in Copilot App.</a:t>
             </a:r>
             <a:endParaRPr lang="en-US" sz="1750" dirty="0"/>
           </a:p>
@@ -30174,7 +30277,7 @@
                 <a:ea typeface="Segoe UI" pitchFamily="34" charset="-122"/>
                 <a:cs typeface="Segoe UI" pitchFamily="34" charset="-120"/>
               </a:rPr>
-              <a:t>Sources: S19, S20, M01, M02, M03, M04  |  Documented surface snapshot: 19 Oct 2026</a:t>
+              <a:t>Sources: S19, S20, S21, S22, S23, M01  |  Documented surface snapshot: 19 Oct 2026</a:t>
             </a:r>
             <a:endParaRPr lang="en-US" sz="900" dirty="0"/>
           </a:p>
@@ -30522,7 +30625,7 @@
                 <a:ea typeface="Segoe UI" pitchFamily="34" charset="-122"/>
                 <a:cs typeface="Segoe UI" pitchFamily="34" charset="-120"/>
               </a:rPr>
-              <a:t>M01</a:t>
+              <a:t>S21</a:t>
             </a:r>
             <a:endParaRPr lang="en-US" sz="2000" dirty="0"/>
           </a:p>
@@ -30570,7 +30673,7 @@
                   </a:extLst>
                 </a:hlinkClick>
               </a:rPr>
-              <a:t>Authentic App/report captures and provenance</a:t>
+              <a:t>Claude Desktop: Chat, Cowork and Code capabilities</a:t>
             </a:r>
             <a:endParaRPr lang="en-US" sz="1900" dirty="0"/>
           </a:p>
@@ -30618,7 +30721,7 @@
                   </a:extLst>
                 </a:hlinkClick>
               </a:rPr>
-              <a:t>github.com/gregunger/ghca-mosaic-challenge-official/blob/4d18656.../presentation/assets/README.md</a:t>
+              <a:t>code.claude.com/docs/en/desktop</a:t>
             </a:r>
             <a:endParaRPr lang="en-US" sz="1050" dirty="0"/>
           </a:p>
@@ -30657,7 +30760,7 @@
                 <a:ea typeface="Segoe UI" pitchFamily="34" charset="-122"/>
                 <a:cs typeface="Segoe UI" pitchFamily="34" charset="-120"/>
               </a:rPr>
-              <a:t>M02</a:t>
+              <a:t>S22</a:t>
             </a:r>
             <a:endParaRPr lang="en-US" sz="2000" dirty="0"/>
           </a:p>
@@ -30705,7 +30808,7 @@
                   </a:extLst>
                 </a:hlinkClick>
               </a:rPr>
-              <a:t>MOSAIC architecture and implementation boundaries</a:t>
+              <a:t>VS Code agent harnesses and shared Copilot runtime</a:t>
             </a:r>
             <a:endParaRPr lang="en-US" sz="1900" dirty="0"/>
           </a:p>
@@ -30753,7 +30856,7 @@
                   </a:extLst>
                 </a:hlinkClick>
               </a:rPr>
-              <a:t>github.com/gregunger/ghca-mosaic-challenge-official/blob/4d18656.../docs/architecture.md</a:t>
+              <a:t>code.visualstudio.com/docs/agents/run/agent-harnesses</a:t>
             </a:r>
             <a:endParaRPr lang="en-US" sz="1050" dirty="0"/>
           </a:p>
@@ -30792,7 +30895,7 @@
                 <a:ea typeface="Segoe UI" pitchFamily="34" charset="-122"/>
                 <a:cs typeface="Segoe UI" pitchFamily="34" charset="-120"/>
               </a:rPr>
-              <a:t>M03</a:t>
+              <a:t>S23</a:t>
             </a:r>
             <a:endParaRPr lang="en-US" sz="2000" dirty="0"/>
           </a:p>
@@ -30840,7 +30943,7 @@
                   </a:extLst>
                 </a:hlinkClick>
               </a:rPr>
-              <a:t>Canonical synthetic dossier and human-review record</a:t>
+              <a:t>Visual Studio agent mode and shared SDK foundation</a:t>
             </a:r>
             <a:endParaRPr lang="en-US" sz="1900" dirty="0"/>
           </a:p>
@@ -30888,7 +30991,7 @@
                   </a:extLst>
                 </a:hlinkClick>
               </a:rPr>
-              <a:t>github.com/gregunger/ghca-mosaic-challenge-official/tree/4d18656.../examples/synthetic/expected</a:t>
+              <a:t>learn.microsoft.com/en-us/visualstudio/ide/copilot-agent-mode?view=visualstudio</a:t>
             </a:r>
             <a:endParaRPr lang="en-US" sz="1050" dirty="0"/>
           </a:p>
@@ -30927,7 +31030,7 @@
                 <a:ea typeface="Segoe UI" pitchFamily="34" charset="-122"/>
                 <a:cs typeface="Segoe UI" pitchFamily="34" charset="-120"/>
               </a:rPr>
-              <a:t>M04</a:t>
+              <a:t>M01</a:t>
             </a:r>
             <a:endParaRPr lang="en-US" sz="2000" dirty="0"/>
           </a:p>
@@ -30975,7 +31078,7 @@
                   </a:extLst>
                 </a:hlinkClick>
               </a:rPr>
-              <a:t>Five configured MOSAIC agent profiles</a:t>
+              <a:t>Authentic App/report captures and provenance</a:t>
             </a:r>
             <a:endParaRPr lang="en-US" sz="1900" dirty="0"/>
           </a:p>
@@ -31023,7 +31126,7 @@
                   </a:extLst>
                 </a:hlinkClick>
               </a:rPr>
-              <a:t>github.com/gregunger/ghca-mosaic-challenge-official/tree/4d18656.../.github/agents</a:t>
+              <a:t>github.com/gregunger/ghca-mosaic-challenge-official/blob/4d18656.../presentation/assets/README.md</a:t>
             </a:r>
             <a:endParaRPr lang="en-US" sz="1050" dirty="0"/>
           </a:p>
@@ -31300,7 +31403,7 @@
                 <a:ea typeface="Segoe UI" pitchFamily="34" charset="-122"/>
                 <a:cs typeface="Segoe UI" pitchFamily="34" charset="-120"/>
               </a:rPr>
-              <a:t>Sources: M05, M06, M07  |  Documented surface snapshot: 19 Oct 2026</a:t>
+              <a:t>Sources: M02, M03, M04, M05, M06, M07  |  Documented surface snapshot: 19 Oct 2026</a:t>
             </a:r>
             <a:endParaRPr lang="en-US" sz="900" dirty="0"/>
           </a:p>
@@ -31378,7 +31481,7 @@
                 <a:ea typeface="Segoe UI" pitchFamily="34" charset="-122"/>
                 <a:cs typeface="Segoe UI" pitchFamily="34" charset="-120"/>
               </a:rPr>
-              <a:t>M05</a:t>
+              <a:t>M02</a:t>
             </a:r>
             <a:endParaRPr lang="en-US" sz="2000" dirty="0"/>
           </a:p>
@@ -31426,7 +31529,7 @@
                   </a:extLst>
                 </a:hlinkClick>
               </a:rPr>
-              <a:t>Illustrative economics and measurement plan</a:t>
+              <a:t>MOSAIC architecture and implementation boundaries</a:t>
             </a:r>
             <a:endParaRPr lang="en-US" sz="1900" dirty="0"/>
           </a:p>
@@ -31474,7 +31577,7 @@
                   </a:extLst>
                 </a:hlinkClick>
               </a:rPr>
-              <a:t>github.com/gregunger/ghca-mosaic-challenge-official/blob/4d18656.../docs/evaluation-plan.md#planning-economics</a:t>
+              <a:t>github.com/gregunger/ghca-mosaic-challenge-official/blob/4d18656.../docs/architecture.md</a:t>
             </a:r>
             <a:endParaRPr lang="en-US" sz="1050" dirty="0"/>
           </a:p>
@@ -31513,7 +31616,7 @@
                 <a:ea typeface="Segoe UI" pitchFamily="34" charset="-122"/>
                 <a:cs typeface="Segoe UI" pitchFamily="34" charset="-120"/>
               </a:rPr>
-              <a:t>M06</a:t>
+              <a:t>M03</a:t>
             </a:r>
             <a:endParaRPr lang="en-US" sz="2000" dirty="0"/>
           </a:p>
@@ -31561,7 +31664,7 @@
                   </a:extLst>
                 </a:hlinkClick>
               </a:rPr>
-              <a:t>Field reuse and adoption path</a:t>
+              <a:t>Canonical synthetic dossier and human-review record</a:t>
             </a:r>
             <a:endParaRPr lang="en-US" sz="1900" dirty="0"/>
           </a:p>
@@ -31609,7 +31712,7 @@
                   </a:extLst>
                 </a:hlinkClick>
               </a:rPr>
-              <a:t>github.com/gregunger/ghca-mosaic-challenge-official/blob/4d18656.../docs/adoption-playbook.md</a:t>
+              <a:t>github.com/gregunger/ghca-mosaic-challenge-official/tree/4d18656.../examples/synthetic/expected</a:t>
             </a:r>
             <a:endParaRPr lang="en-US" sz="1050" dirty="0"/>
           </a:p>
@@ -31648,7 +31751,7 @@
                 <a:ea typeface="Segoe UI" pitchFamily="34" charset="-122"/>
                 <a:cs typeface="Segoe UI" pitchFamily="34" charset="-120"/>
               </a:rPr>
-              <a:t>M07</a:t>
+              <a:t>M04</a:t>
             </a:r>
             <a:endParaRPr lang="en-US" sz="2000" dirty="0"/>
           </a:p>
@@ -31696,7 +31799,7 @@
                   </a:extLst>
                 </a:hlinkClick>
               </a:rPr>
-              <a:t>Observed App skill and read-only MCP rehearsal</a:t>
+              <a:t>Five configured MOSAIC agent profiles</a:t>
             </a:r>
             <a:endParaRPr lang="en-US" sz="1900" dirty="0"/>
           </a:p>
@@ -31744,6 +31847,411 @@
                   </a:extLst>
                 </a:hlinkClick>
               </a:rPr>
+              <a:t>github.com/gregunger/ghca-mosaic-challenge-official/tree/4d18656.../.github/agents</a:t>
+            </a:r>
+            <a:endParaRPr lang="en-US" sz="1050" dirty="0"/>
+          </a:p>
+        </p:txBody>
+      </p:sp>
+      <p:sp>
+        <p:nvSpPr>
+          <p:cNvPr id="18" name="content"/>
+          <p:cNvSpPr txBox="1"/>
+          <p:nvPr/>
+        </p:nvSpPr>
+        <p:spPr>
+          <a:xfrm>
+            <a:off x="658368" y="3767328"/>
+            <a:ext cx="621792" cy="365760"/>
+          </a:xfrm>
+          <a:prstGeom prst="rect">
+            <a:avLst/>
+          </a:prstGeom>
+          <a:noFill/>
+          <a:ln/>
+        </p:spPr>
+        <p:txBody>
+          <a:bodyPr wrap="square" lIns="0" tIns="0" rIns="0" bIns="0" rtlCol="0" anchor="ctr"/>
+          <a:lstStyle/>
+          <a:p>
+            <a:pPr indent="0" marL="0">
+              <a:buNone/>
+            </a:pPr>
+            <a:r>
+              <a:rPr lang="en-US" sz="2000" b="1" dirty="0">
+                <a:solidFill>
+                  <a:srgbClr val="0969DA"/>
+                </a:solidFill>
+                <a:latin typeface="Segoe UI" pitchFamily="34" charset="0"/>
+                <a:ea typeface="Segoe UI" pitchFamily="34" charset="-122"/>
+                <a:cs typeface="Segoe UI" pitchFamily="34" charset="-120"/>
+              </a:rPr>
+              <a:t>M05</a:t>
+            </a:r>
+            <a:endParaRPr lang="en-US" sz="2000" dirty="0"/>
+          </a:p>
+        </p:txBody>
+      </p:sp>
+      <p:sp>
+        <p:nvSpPr>
+          <p:cNvPr id="19" name="content">
+            <a:hlinkClick r:id="rId7" tooltip=""/>
+          </p:cNvPr>
+          <p:cNvSpPr txBox="1"/>
+          <p:nvPr/>
+        </p:nvSpPr>
+        <p:spPr>
+          <a:xfrm>
+            <a:off x="1426464" y="3767328"/>
+            <a:ext cx="9884664" cy="329184"/>
+          </a:xfrm>
+          <a:prstGeom prst="rect">
+            <a:avLst/>
+          </a:prstGeom>
+          <a:noFill/>
+          <a:ln/>
+        </p:spPr>
+        <p:txBody>
+          <a:bodyPr wrap="square" lIns="0" tIns="0" rIns="0" bIns="0" rtlCol="0" anchor="ctr"/>
+          <a:lstStyle/>
+          <a:p>
+            <a:pPr indent="0" marL="0">
+              <a:buNone/>
+            </a:pPr>
+            <a:r>
+              <a:rPr lang="en-US" sz="1900" b="1" u="sng" dirty="0">
+                <a:solidFill>
+                  <a:srgbClr val="14202B"/>
+                </a:solidFill>
+                <a:latin typeface="Segoe UI" pitchFamily="34" charset="0"/>
+                <a:ea typeface="Segoe UI" pitchFamily="34" charset="-122"/>
+                <a:cs typeface="Segoe UI" pitchFamily="34" charset="-120"/>
+                <a:hlinkClick r:id="rId7" invalidUrl="" action="" tgtFrame="" tooltip="" history="1" highlightClick="0" endSnd="0">
+                  <a:extLst>
+                    <a:ext uri="{A12FA001-AC4F-418D-AE19-62706E023703}">
+                      <ahyp:hlinkClr xmlns:ahyp="http://schemas.microsoft.com/office/drawing/2018/hyperlinkcolor" val="tx"/>
+                    </a:ext>
+                  </a:extLst>
+                </a:hlinkClick>
+              </a:rPr>
+              <a:t>Illustrative economics and measurement plan</a:t>
+            </a:r>
+            <a:endParaRPr lang="en-US" sz="1900" dirty="0"/>
+          </a:p>
+        </p:txBody>
+      </p:sp>
+      <p:sp>
+        <p:nvSpPr>
+          <p:cNvPr id="20" name="citation">
+            <a:hlinkClick r:id="rId8" tooltip=""/>
+          </p:cNvPr>
+          <p:cNvSpPr txBox="1"/>
+          <p:nvPr/>
+        </p:nvSpPr>
+        <p:spPr>
+          <a:xfrm>
+            <a:off x="1426464" y="4142232"/>
+            <a:ext cx="9884664" cy="219456"/>
+          </a:xfrm>
+          <a:prstGeom prst="rect">
+            <a:avLst/>
+          </a:prstGeom>
+          <a:noFill/>
+          <a:ln/>
+        </p:spPr>
+        <p:txBody>
+          <a:bodyPr wrap="square" lIns="0" tIns="0" rIns="0" bIns="0" rtlCol="0" anchor="ctr"/>
+          <a:lstStyle/>
+          <a:p>
+            <a:pPr indent="0" marL="0">
+              <a:buNone/>
+            </a:pPr>
+            <a:r>
+              <a:rPr lang="en-US" sz="1050" u="sng" dirty="0">
+                <a:solidFill>
+                  <a:srgbClr val="526174"/>
+                </a:solidFill>
+                <a:latin typeface="Segoe UI" pitchFamily="34" charset="0"/>
+                <a:ea typeface="Segoe UI" pitchFamily="34" charset="-122"/>
+                <a:cs typeface="Segoe UI" pitchFamily="34" charset="-120"/>
+                <a:hlinkClick r:id="rId8" invalidUrl="" action="" tgtFrame="" tooltip="" history="1" highlightClick="0" endSnd="0">
+                  <a:extLst>
+                    <a:ext uri="{A12FA001-AC4F-418D-AE19-62706E023703}">
+                      <ahyp:hlinkClr xmlns:ahyp="http://schemas.microsoft.com/office/drawing/2018/hyperlinkcolor" val="tx"/>
+                    </a:ext>
+                  </a:extLst>
+                </a:hlinkClick>
+              </a:rPr>
+              <a:t>github.com/gregunger/ghca-mosaic-challenge-official/blob/4d18656.../docs/evaluation-plan.md#planning-economics</a:t>
+            </a:r>
+            <a:endParaRPr lang="en-US" sz="1050" dirty="0"/>
+          </a:p>
+        </p:txBody>
+      </p:sp>
+      <p:sp>
+        <p:nvSpPr>
+          <p:cNvPr id="21" name="content"/>
+          <p:cNvSpPr txBox="1"/>
+          <p:nvPr/>
+        </p:nvSpPr>
+        <p:spPr>
+          <a:xfrm>
+            <a:off x="658368" y="4407408"/>
+            <a:ext cx="621792" cy="365760"/>
+          </a:xfrm>
+          <a:prstGeom prst="rect">
+            <a:avLst/>
+          </a:prstGeom>
+          <a:noFill/>
+          <a:ln/>
+        </p:spPr>
+        <p:txBody>
+          <a:bodyPr wrap="square" lIns="0" tIns="0" rIns="0" bIns="0" rtlCol="0" anchor="ctr"/>
+          <a:lstStyle/>
+          <a:p>
+            <a:pPr indent="0" marL="0">
+              <a:buNone/>
+            </a:pPr>
+            <a:r>
+              <a:rPr lang="en-US" sz="2000" b="1" dirty="0">
+                <a:solidFill>
+                  <a:srgbClr val="0969DA"/>
+                </a:solidFill>
+                <a:latin typeface="Segoe UI" pitchFamily="34" charset="0"/>
+                <a:ea typeface="Segoe UI" pitchFamily="34" charset="-122"/>
+                <a:cs typeface="Segoe UI" pitchFamily="34" charset="-120"/>
+              </a:rPr>
+              <a:t>M06</a:t>
+            </a:r>
+            <a:endParaRPr lang="en-US" sz="2000" dirty="0"/>
+          </a:p>
+        </p:txBody>
+      </p:sp>
+      <p:sp>
+        <p:nvSpPr>
+          <p:cNvPr id="22" name="content">
+            <a:hlinkClick r:id="rId9" tooltip=""/>
+          </p:cNvPr>
+          <p:cNvSpPr txBox="1"/>
+          <p:nvPr/>
+        </p:nvSpPr>
+        <p:spPr>
+          <a:xfrm>
+            <a:off x="1426464" y="4407408"/>
+            <a:ext cx="9884664" cy="329184"/>
+          </a:xfrm>
+          <a:prstGeom prst="rect">
+            <a:avLst/>
+          </a:prstGeom>
+          <a:noFill/>
+          <a:ln/>
+        </p:spPr>
+        <p:txBody>
+          <a:bodyPr wrap="square" lIns="0" tIns="0" rIns="0" bIns="0" rtlCol="0" anchor="ctr"/>
+          <a:lstStyle/>
+          <a:p>
+            <a:pPr indent="0" marL="0">
+              <a:buNone/>
+            </a:pPr>
+            <a:r>
+              <a:rPr lang="en-US" sz="1900" b="1" u="sng" dirty="0">
+                <a:solidFill>
+                  <a:srgbClr val="14202B"/>
+                </a:solidFill>
+                <a:latin typeface="Segoe UI" pitchFamily="34" charset="0"/>
+                <a:ea typeface="Segoe UI" pitchFamily="34" charset="-122"/>
+                <a:cs typeface="Segoe UI" pitchFamily="34" charset="-120"/>
+                <a:hlinkClick r:id="rId9" invalidUrl="" action="" tgtFrame="" tooltip="" history="1" highlightClick="0" endSnd="0">
+                  <a:extLst>
+                    <a:ext uri="{A12FA001-AC4F-418D-AE19-62706E023703}">
+                      <ahyp:hlinkClr xmlns:ahyp="http://schemas.microsoft.com/office/drawing/2018/hyperlinkcolor" val="tx"/>
+                    </a:ext>
+                  </a:extLst>
+                </a:hlinkClick>
+              </a:rPr>
+              <a:t>Field reuse and adoption path</a:t>
+            </a:r>
+            <a:endParaRPr lang="en-US" sz="1900" dirty="0"/>
+          </a:p>
+        </p:txBody>
+      </p:sp>
+      <p:sp>
+        <p:nvSpPr>
+          <p:cNvPr id="23" name="citation">
+            <a:hlinkClick r:id="rId10" tooltip=""/>
+          </p:cNvPr>
+          <p:cNvSpPr txBox="1"/>
+          <p:nvPr/>
+        </p:nvSpPr>
+        <p:spPr>
+          <a:xfrm>
+            <a:off x="1426464" y="4782312"/>
+            <a:ext cx="9884664" cy="219456"/>
+          </a:xfrm>
+          <a:prstGeom prst="rect">
+            <a:avLst/>
+          </a:prstGeom>
+          <a:noFill/>
+          <a:ln/>
+        </p:spPr>
+        <p:txBody>
+          <a:bodyPr wrap="square" lIns="0" tIns="0" rIns="0" bIns="0" rtlCol="0" anchor="ctr"/>
+          <a:lstStyle/>
+          <a:p>
+            <a:pPr indent="0" marL="0">
+              <a:buNone/>
+            </a:pPr>
+            <a:r>
+              <a:rPr lang="en-US" sz="1050" u="sng" dirty="0">
+                <a:solidFill>
+                  <a:srgbClr val="526174"/>
+                </a:solidFill>
+                <a:latin typeface="Segoe UI" pitchFamily="34" charset="0"/>
+                <a:ea typeface="Segoe UI" pitchFamily="34" charset="-122"/>
+                <a:cs typeface="Segoe UI" pitchFamily="34" charset="-120"/>
+                <a:hlinkClick r:id="rId10" invalidUrl="" action="" tgtFrame="" tooltip="" history="1" highlightClick="0" endSnd="0">
+                  <a:extLst>
+                    <a:ext uri="{A12FA001-AC4F-418D-AE19-62706E023703}">
+                      <ahyp:hlinkClr xmlns:ahyp="http://schemas.microsoft.com/office/drawing/2018/hyperlinkcolor" val="tx"/>
+                    </a:ext>
+                  </a:extLst>
+                </a:hlinkClick>
+              </a:rPr>
+              <a:t>github.com/gregunger/ghca-mosaic-challenge-official/blob/4d18656.../docs/adoption-playbook.md</a:t>
+            </a:r>
+            <a:endParaRPr lang="en-US" sz="1050" dirty="0"/>
+          </a:p>
+        </p:txBody>
+      </p:sp>
+      <p:sp>
+        <p:nvSpPr>
+          <p:cNvPr id="24" name="content"/>
+          <p:cNvSpPr txBox="1"/>
+          <p:nvPr/>
+        </p:nvSpPr>
+        <p:spPr>
+          <a:xfrm>
+            <a:off x="658368" y="5047488"/>
+            <a:ext cx="621792" cy="365760"/>
+          </a:xfrm>
+          <a:prstGeom prst="rect">
+            <a:avLst/>
+          </a:prstGeom>
+          <a:noFill/>
+          <a:ln/>
+        </p:spPr>
+        <p:txBody>
+          <a:bodyPr wrap="square" lIns="0" tIns="0" rIns="0" bIns="0" rtlCol="0" anchor="ctr"/>
+          <a:lstStyle/>
+          <a:p>
+            <a:pPr indent="0" marL="0">
+              <a:buNone/>
+            </a:pPr>
+            <a:r>
+              <a:rPr lang="en-US" sz="2000" b="1" dirty="0">
+                <a:solidFill>
+                  <a:srgbClr val="0969DA"/>
+                </a:solidFill>
+                <a:latin typeface="Segoe UI" pitchFamily="34" charset="0"/>
+                <a:ea typeface="Segoe UI" pitchFamily="34" charset="-122"/>
+                <a:cs typeface="Segoe UI" pitchFamily="34" charset="-120"/>
+              </a:rPr>
+              <a:t>M07</a:t>
+            </a:r>
+            <a:endParaRPr lang="en-US" sz="2000" dirty="0"/>
+          </a:p>
+        </p:txBody>
+      </p:sp>
+      <p:sp>
+        <p:nvSpPr>
+          <p:cNvPr id="25" name="content">
+            <a:hlinkClick r:id="rId11" tooltip=""/>
+          </p:cNvPr>
+          <p:cNvSpPr txBox="1"/>
+          <p:nvPr/>
+        </p:nvSpPr>
+        <p:spPr>
+          <a:xfrm>
+            <a:off x="1426464" y="5047488"/>
+            <a:ext cx="9884664" cy="329184"/>
+          </a:xfrm>
+          <a:prstGeom prst="rect">
+            <a:avLst/>
+          </a:prstGeom>
+          <a:noFill/>
+          <a:ln/>
+        </p:spPr>
+        <p:txBody>
+          <a:bodyPr wrap="square" lIns="0" tIns="0" rIns="0" bIns="0" rtlCol="0" anchor="ctr"/>
+          <a:lstStyle/>
+          <a:p>
+            <a:pPr indent="0" marL="0">
+              <a:buNone/>
+            </a:pPr>
+            <a:r>
+              <a:rPr lang="en-US" sz="1900" b="1" u="sng" dirty="0">
+                <a:solidFill>
+                  <a:srgbClr val="14202B"/>
+                </a:solidFill>
+                <a:latin typeface="Segoe UI" pitchFamily="34" charset="0"/>
+                <a:ea typeface="Segoe UI" pitchFamily="34" charset="-122"/>
+                <a:cs typeface="Segoe UI" pitchFamily="34" charset="-120"/>
+                <a:hlinkClick r:id="rId11" invalidUrl="" action="" tgtFrame="" tooltip="" history="1" highlightClick="0" endSnd="0">
+                  <a:extLst>
+                    <a:ext uri="{A12FA001-AC4F-418D-AE19-62706E023703}">
+                      <ahyp:hlinkClr xmlns:ahyp="http://schemas.microsoft.com/office/drawing/2018/hyperlinkcolor" val="tx"/>
+                    </a:ext>
+                  </a:extLst>
+                </a:hlinkClick>
+              </a:rPr>
+              <a:t>Observed App skill and read-only MCP rehearsal</a:t>
+            </a:r>
+            <a:endParaRPr lang="en-US" sz="1900" dirty="0"/>
+          </a:p>
+        </p:txBody>
+      </p:sp>
+      <p:sp>
+        <p:nvSpPr>
+          <p:cNvPr id="26" name="citation">
+            <a:hlinkClick r:id="rId12" tooltip=""/>
+          </p:cNvPr>
+          <p:cNvSpPr txBox="1"/>
+          <p:nvPr/>
+        </p:nvSpPr>
+        <p:spPr>
+          <a:xfrm>
+            <a:off x="1426464" y="5422392"/>
+            <a:ext cx="9884664" cy="219456"/>
+          </a:xfrm>
+          <a:prstGeom prst="rect">
+            <a:avLst/>
+          </a:prstGeom>
+          <a:noFill/>
+          <a:ln/>
+        </p:spPr>
+        <p:txBody>
+          <a:bodyPr wrap="square" lIns="0" tIns="0" rIns="0" bIns="0" rtlCol="0" anchor="ctr"/>
+          <a:lstStyle/>
+          <a:p>
+            <a:pPr indent="0" marL="0">
+              <a:buNone/>
+            </a:pPr>
+            <a:r>
+              <a:rPr lang="en-US" sz="1050" u="sng" dirty="0">
+                <a:solidFill>
+                  <a:srgbClr val="526174"/>
+                </a:solidFill>
+                <a:latin typeface="Segoe UI" pitchFamily="34" charset="0"/>
+                <a:ea typeface="Segoe UI" pitchFamily="34" charset="-122"/>
+                <a:cs typeface="Segoe UI" pitchFamily="34" charset="-120"/>
+                <a:hlinkClick r:id="rId12" invalidUrl="" action="" tgtFrame="" tooltip="" history="1" highlightClick="0" endSnd="0">
+                  <a:extLst>
+                    <a:ext uri="{A12FA001-AC4F-418D-AE19-62706E023703}">
+                      <ahyp:hlinkClr xmlns:ahyp="http://schemas.microsoft.com/office/drawing/2018/hyperlinkcolor" val="tx"/>
+                    </a:ext>
+                  </a:extLst>
+                </a:hlinkClick>
+              </a:rPr>
               <a:t>github.com/gregunger/ghca-mosaic-challenge-official/blob/4d18656.../docs/product-feedback-observation-log.md</a:t>
             </a:r>
             <a:endParaRPr lang="en-US" sz="1050" dirty="0"/>
@@ -31752,7 +32260,7 @@
       </p:sp>
       <p:sp>
         <p:nvSpPr>
-          <p:cNvPr id="18" name="layout-panel"/>
+          <p:cNvPr id="27" name="layout-panel"/>
           <p:cNvSpPr/>
           <p:nvPr/>
         </p:nvSpPr>
@@ -31779,7 +32287,7 @@
       </p:sp>
       <p:sp>
         <p:nvSpPr>
-          <p:cNvPr id="19" name="takeaway"/>
+          <p:cNvPr id="28" name="takeaway"/>
           <p:cNvSpPr txBox="1"/>
           <p:nvPr/>
         </p:nvSpPr>

</xml_diff>